<commit_message>
Update pricing to Stripe rates: Pro €49/mo, Enterprise €299/mo
- Investor deck: updated unit economics slide (€588/yr Pro, €3,588/yr Enterprise)
- Landing page: added 3-tier pricing section (Free/Pro/Enterprise)
- CLAUDE.md: updated memory with pricing changes and session log

Co-Authored-By: Claude Opus 4.6 <noreply@anthropic.com>
</commit_message>
<xml_diff>
--- a/cycleCAD-Investor-Deck.pptx
+++ b/cycleCAD-Investor-Deck.pptx
@@ -2746,7 +2746,7 @@
                 <a:ea typeface="Calibri" pitchFamily="34" charset="-122"/>
                 <a:cs typeface="Calibri" pitchFamily="34" charset="-120"/>
               </a:rPr>
-              <a:t>  ×  </a:t>
+              <a:t xml:space="preserve">  ×  </a:t>
             </a:r>
             <a:pPr indent="0" marL="0">
               <a:buNone/>
@@ -2807,7 +2807,7 @@
       </p:sp>
       <p:pic>
         <p:nvPicPr>
-          <p:cNvPr id="6" name="Image 0" descr="preencoded.png">    </p:cNvPr>
+          <p:cNvPr id="6" name="Image 0" descr="preencoded.png"/>
           <p:cNvPicPr>
             <a:picLocks noChangeAspect="1"/>
           </p:cNvPicPr>
@@ -3564,7 +3564,7 @@
       </p:sp>
       <p:pic>
         <p:nvPicPr>
-          <p:cNvPr id="6" name="Image 0" descr="preencoded.png">    </p:cNvPr>
+          <p:cNvPr id="6" name="Image 0" descr="preencoded.png"/>
           <p:cNvPicPr>
             <a:picLocks noChangeAspect="1"/>
           </p:cNvPicPr>
@@ -3713,7 +3713,7 @@
       </p:sp>
       <p:pic>
         <p:nvPicPr>
-          <p:cNvPr id="11" name="Image 1" descr="preencoded.png">    </p:cNvPr>
+          <p:cNvPr id="11" name="Image 1" descr="preencoded.png"/>
           <p:cNvPicPr>
             <a:picLocks noChangeAspect="1"/>
           </p:cNvPicPr>
@@ -3862,7 +3862,7 @@
       </p:sp>
       <p:pic>
         <p:nvPicPr>
-          <p:cNvPr id="16" name="Image 2" descr="preencoded.png">    </p:cNvPr>
+          <p:cNvPr id="16" name="Image 2" descr="preencoded.png"/>
           <p:cNvPicPr>
             <a:picLocks noChangeAspect="1"/>
           </p:cNvPicPr>
@@ -4011,7 +4011,7 @@
       </p:sp>
       <p:pic>
         <p:nvPicPr>
-          <p:cNvPr id="21" name="Image 3" descr="preencoded.png">    </p:cNvPr>
+          <p:cNvPr id="21" name="Image 3" descr="preencoded.png"/>
           <p:cNvPicPr>
             <a:picLocks noChangeAspect="1"/>
           </p:cNvPicPr>
@@ -4160,7 +4160,7 @@
       </p:sp>
       <p:pic>
         <p:nvPicPr>
-          <p:cNvPr id="26" name="Image 4" descr="preencoded.png">    </p:cNvPr>
+          <p:cNvPr id="26" name="Image 4" descr="preencoded.png"/>
           <p:cNvPicPr>
             <a:picLocks noChangeAspect="1"/>
           </p:cNvPicPr>
@@ -4309,7 +4309,7 @@
       </p:sp>
       <p:pic>
         <p:nvPicPr>
-          <p:cNvPr id="31" name="Image 5" descr="preencoded.png">    </p:cNvPr>
+          <p:cNvPr id="31" name="Image 5" descr="preencoded.png"/>
           <p:cNvPicPr>
             <a:picLocks noChangeAspect="1"/>
           </p:cNvPicPr>
@@ -7112,7 +7112,7 @@
       </p:sp>
       <p:pic>
         <p:nvPicPr>
-          <p:cNvPr id="29" name="Image 0" descr="preencoded.png">    </p:cNvPr>
+          <p:cNvPr id="29" name="Image 0" descr="preencoded.png"/>
           <p:cNvPicPr>
             <a:picLocks noChangeAspect="1"/>
           </p:cNvPicPr>
@@ -7175,7 +7175,7 @@
       </p:sp>
       <p:pic>
         <p:nvPicPr>
-          <p:cNvPr id="31" name="Image 1" descr="preencoded.png">    </p:cNvPr>
+          <p:cNvPr id="31" name="Image 1" descr="preencoded.png"/>
           <p:cNvPicPr>
             <a:picLocks noChangeAspect="1"/>
           </p:cNvPicPr>
@@ -7238,7 +7238,7 @@
       </p:sp>
       <p:pic>
         <p:nvPicPr>
-          <p:cNvPr id="33" name="Image 2" descr="preencoded.png">    </p:cNvPr>
+          <p:cNvPr id="33" name="Image 2" descr="preencoded.png"/>
           <p:cNvPicPr>
             <a:picLocks noChangeAspect="1"/>
           </p:cNvPicPr>
@@ -7301,7 +7301,7 @@
       </p:sp>
       <p:pic>
         <p:nvPicPr>
-          <p:cNvPr id="35" name="Image 3" descr="preencoded.png">    </p:cNvPr>
+          <p:cNvPr id="35" name="Image 3" descr="preencoded.png"/>
           <p:cNvPicPr>
             <a:picLocks noChangeAspect="1"/>
           </p:cNvPicPr>
@@ -7450,7 +7450,7 @@
       </p:sp>
       <p:pic>
         <p:nvPicPr>
-          <p:cNvPr id="40" name="Image 4" descr="preencoded.png">    </p:cNvPr>
+          <p:cNvPr id="40" name="Image 4" descr="preencoded.png"/>
           <p:cNvPicPr>
             <a:picLocks noChangeAspect="1"/>
           </p:cNvPicPr>
@@ -7513,7 +7513,7 @@
       </p:sp>
       <p:pic>
         <p:nvPicPr>
-          <p:cNvPr id="42" name="Image 5" descr="preencoded.png">    </p:cNvPr>
+          <p:cNvPr id="42" name="Image 5" descr="preencoded.png"/>
           <p:cNvPicPr>
             <a:picLocks noChangeAspect="1"/>
           </p:cNvPicPr>
@@ -7576,7 +7576,7 @@
       </p:sp>
       <p:pic>
         <p:nvPicPr>
-          <p:cNvPr id="44" name="Image 6" descr="preencoded.png">    </p:cNvPr>
+          <p:cNvPr id="44" name="Image 6" descr="preencoded.png"/>
           <p:cNvPicPr>
             <a:picLocks noChangeAspect="1"/>
           </p:cNvPicPr>
@@ -7639,7 +7639,7 @@
       </p:sp>
       <p:pic>
         <p:nvPicPr>
-          <p:cNvPr id="46" name="Image 7" descr="preencoded.png">    </p:cNvPr>
+          <p:cNvPr id="46" name="Image 7" descr="preencoded.png"/>
           <p:cNvPicPr>
             <a:picLocks noChangeAspect="1"/>
           </p:cNvPicPr>
@@ -7780,7 +7780,7 @@
                 <a:ea typeface="Arial Black" pitchFamily="34" charset="-122"/>
                 <a:cs typeface="Arial Black" pitchFamily="34" charset="-120"/>
               </a:rPr>
-              <a:t>♻️  THE FLYWHEEL:  </a:t>
+              <a:t xml:space="preserve">♻️  THE FLYWHEEL:  </a:t>
             </a:r>
             <a:pPr indent="0" marL="0">
               <a:buNone/>
@@ -7920,7 +7920,7 @@
       </p:sp>
       <p:pic>
         <p:nvPicPr>
-          <p:cNvPr id="5" name="Image 0" descr="preencoded.png">    </p:cNvPr>
+          <p:cNvPr id="5" name="Image 0" descr="preencoded.png"/>
           <p:cNvPicPr>
             <a:picLocks noChangeAspect="1"/>
           </p:cNvPicPr>
@@ -8069,7 +8069,7 @@
       </p:sp>
       <p:pic>
         <p:nvPicPr>
-          <p:cNvPr id="10" name="Image 1" descr="preencoded.png">    </p:cNvPr>
+          <p:cNvPr id="10" name="Image 1" descr="preencoded.png"/>
           <p:cNvPicPr>
             <a:picLocks noChangeAspect="1"/>
           </p:cNvPicPr>
@@ -8218,7 +8218,7 @@
       </p:sp>
       <p:pic>
         <p:nvPicPr>
-          <p:cNvPr id="15" name="Image 2" descr="preencoded.png">    </p:cNvPr>
+          <p:cNvPr id="15" name="Image 2" descr="preencoded.png"/>
           <p:cNvPicPr>
             <a:picLocks noChangeAspect="1"/>
           </p:cNvPicPr>
@@ -8367,7 +8367,7 @@
       </p:sp>
       <p:pic>
         <p:nvPicPr>
-          <p:cNvPr id="20" name="Image 3" descr="preencoded.png">    </p:cNvPr>
+          <p:cNvPr id="20" name="Image 3" descr="preencoded.png"/>
           <p:cNvPicPr>
             <a:picLocks noChangeAspect="1"/>
           </p:cNvPicPr>
@@ -9640,7 +9640,7 @@
       </p:sp>
       <p:pic>
         <p:nvPicPr>
-          <p:cNvPr id="5" name="Image 0" descr="preencoded.png">    </p:cNvPr>
+          <p:cNvPr id="5" name="Image 0" descr="preencoded.png"/>
           <p:cNvPicPr>
             <a:picLocks noChangeAspect="1"/>
           </p:cNvPicPr>
@@ -9770,7 +9770,7 @@
                   <a:srgbClr val="8B9AB5"/>
                 </a:solidFill>
               </a:rPr>
-              <a:t>Founder of cycleWASH — built and shipped real bicycle washing machines used in production. </a:t>
+              <a:t xml:space="preserve">Founder of cycleWASH — built and shipped real bicycle washing machines used in production. </a:t>
             </a:r>
             <a:pPr indent="0" marL="0">
               <a:buNone/>
@@ -9781,7 +9781,7 @@
                   <a:srgbClr val="8B9AB5"/>
                 </a:solidFill>
               </a:rPr>
-              <a:t>Deep domain expertise in mechanical engineering and industrial equipment. </a:t>
+              <a:t xml:space="preserve">Deep domain expertise in mechanical engineering and industrial equipment. </a:t>
             </a:r>
             <a:pPr indent="0" marL="0">
               <a:buNone/>
@@ -9847,7 +9847,7 @@
       </p:sp>
       <p:pic>
         <p:nvPicPr>
-          <p:cNvPr id="11" name="Image 1" descr="preencoded.png">    </p:cNvPr>
+          <p:cNvPr id="11" name="Image 1" descr="preencoded.png"/>
           <p:cNvPicPr>
             <a:picLocks noChangeAspect="1"/>
           </p:cNvPicPr>
@@ -11988,7 +11988,7 @@
       </p:sp>
       <p:pic>
         <p:nvPicPr>
-          <p:cNvPr id="6" name="Image 0" descr="preencoded.png">    </p:cNvPr>
+          <p:cNvPr id="6" name="Image 0" descr="preencoded.png"/>
           <p:cNvPicPr>
             <a:picLocks noChangeAspect="1"/>
           </p:cNvPicPr>
@@ -12137,7 +12137,7 @@
       </p:sp>
       <p:pic>
         <p:nvPicPr>
-          <p:cNvPr id="11" name="Image 1" descr="preencoded.png">    </p:cNvPr>
+          <p:cNvPr id="11" name="Image 1" descr="preencoded.png"/>
           <p:cNvPicPr>
             <a:picLocks noChangeAspect="1"/>
           </p:cNvPicPr>
@@ -12286,7 +12286,7 @@
       </p:sp>
       <p:pic>
         <p:nvPicPr>
-          <p:cNvPr id="16" name="Image 2" descr="preencoded.png">    </p:cNvPr>
+          <p:cNvPr id="16" name="Image 2" descr="preencoded.png"/>
           <p:cNvPicPr>
             <a:picLocks noChangeAspect="1"/>
           </p:cNvPicPr>
@@ -12435,7 +12435,7 @@
       </p:sp>
       <p:pic>
         <p:nvPicPr>
-          <p:cNvPr id="21" name="Image 3" descr="preencoded.png">    </p:cNvPr>
+          <p:cNvPr id="21" name="Image 3" descr="preencoded.png"/>
           <p:cNvPicPr>
             <a:picLocks noChangeAspect="1"/>
           </p:cNvPicPr>
@@ -12584,7 +12584,7 @@
       </p:sp>
       <p:pic>
         <p:nvPicPr>
-          <p:cNvPr id="26" name="Image 4" descr="preencoded.png">    </p:cNvPr>
+          <p:cNvPr id="26" name="Image 4" descr="preencoded.png"/>
           <p:cNvPicPr>
             <a:picLocks noChangeAspect="1"/>
           </p:cNvPicPr>
@@ -12733,7 +12733,7 @@
       </p:sp>
       <p:pic>
         <p:nvPicPr>
-          <p:cNvPr id="31" name="Image 5" descr="preencoded.png">    </p:cNvPr>
+          <p:cNvPr id="31" name="Image 5" descr="preencoded.png"/>
           <p:cNvPicPr>
             <a:picLocks noChangeAspect="1"/>
           </p:cNvPicPr>
@@ -15874,7 +15874,7 @@
                 <a:ea typeface="Calibri" pitchFamily="34" charset="-122"/>
                 <a:cs typeface="Calibri" pitchFamily="34" charset="-120"/>
               </a:rPr>
-              <a:t>Token economics: free tier drives adoption, $CYCLE token consumption + enterprise agents drive revenue</a:t>
+              <a:t>Token economics: free tier drives adoption, Pro €49/mo + Enterprise €299/mo drive revenue</a:t>
             </a:r>
             <a:endParaRPr lang="en-US" sz="1200" dirty="0"/>
           </a:p>
@@ -15960,7 +15960,7 @@
                 <a:ea typeface="Calibri" pitchFamily="34" charset="-122"/>
                 <a:cs typeface="Calibri" pitchFamily="34" charset="-120"/>
               </a:rPr>
-              <a:t>Avg Token Revenue</a:t>
+              <a:t>Pro Tier ARR</a:t>
             </a:r>
             <a:endParaRPr lang="en-US" sz="1000" dirty="0"/>
           </a:p>
@@ -15999,7 +15999,7 @@
                 <a:ea typeface="Arial Black" pitchFamily="34" charset="-122"/>
                 <a:cs typeface="Arial Black" pitchFamily="34" charset="-120"/>
               </a:rPr>
-              <a:t>$588/yr</a:t>
+              <a:t>€588/yr</a:t>
             </a:r>
             <a:endParaRPr lang="en-US" sz="2200" dirty="0"/>
           </a:p>
@@ -16038,7 +16038,7 @@
                 <a:ea typeface="Calibri" pitchFamily="34" charset="-122"/>
                 <a:cs typeface="Calibri" pitchFamily="34" charset="-120"/>
               </a:rPr>
-              <a:t>Per active token buyer — usage-based consumption</a:t>
+              <a:t>€49/mo per Pro subscriber</a:t>
             </a:r>
             <a:endParaRPr lang="en-US" sz="900" dirty="0"/>
           </a:p>
@@ -16163,7 +16163,7 @@
                 <a:ea typeface="Arial Black" pitchFamily="34" charset="-122"/>
                 <a:cs typeface="Arial Black" pitchFamily="34" charset="-120"/>
               </a:rPr>
-              <a:t>$48K/yr</a:t>
+              <a:t>€3,588/yr</a:t>
             </a:r>
             <a:endParaRPr lang="en-US" sz="2200" dirty="0"/>
           </a:p>
@@ -16202,7 +16202,7 @@
                 <a:ea typeface="Calibri" pitchFamily="34" charset="-122"/>
                 <a:cs typeface="Calibri" pitchFamily="34" charset="-120"/>
               </a:rPr>
-              <a:t>Enterprise agent fleets — high-volume token packages</a:t>
+              <a:t>€299/mo per Enterprise subscriber</a:t>
             </a:r>
             <a:endParaRPr lang="en-US" sz="900" dirty="0"/>
           </a:p>
@@ -17753,7 +17753,7 @@
       </p:sp>
       <p:pic>
         <p:nvPicPr>
-          <p:cNvPr id="6" name="Image 0" descr="preencoded.png">    </p:cNvPr>
+          <p:cNvPr id="6" name="Image 0" descr="preencoded.png"/>
           <p:cNvPicPr>
             <a:picLocks noChangeAspect="1"/>
           </p:cNvPicPr>
@@ -17902,7 +17902,7 @@
       </p:sp>
       <p:pic>
         <p:nvPicPr>
-          <p:cNvPr id="11" name="Image 1" descr="preencoded.png">    </p:cNvPr>
+          <p:cNvPr id="11" name="Image 1" descr="preencoded.png"/>
           <p:cNvPicPr>
             <a:picLocks noChangeAspect="1"/>
           </p:cNvPicPr>
@@ -18051,7 +18051,7 @@
       </p:sp>
       <p:pic>
         <p:nvPicPr>
-          <p:cNvPr id="16" name="Image 2" descr="preencoded.png">    </p:cNvPr>
+          <p:cNvPr id="16" name="Image 2" descr="preencoded.png"/>
           <p:cNvPicPr>
             <a:picLocks noChangeAspect="1"/>
           </p:cNvPicPr>
@@ -19265,7 +19265,7 @@
                 <a:ea typeface="Calibri" pitchFamily="34" charset="-122"/>
                 <a:cs typeface="Calibri" pitchFamily="34" charset="-120"/>
               </a:rPr>
-              <a:t>  ×  </a:t>
+              <a:t xml:space="preserve">  ×  </a:t>
             </a:r>
             <a:pPr indent="0" marL="0">
               <a:buNone/>
@@ -19287,7 +19287,7 @@
       </p:sp>
       <p:pic>
         <p:nvPicPr>
-          <p:cNvPr id="5" name="Image 0" descr="preencoded.png">    </p:cNvPr>
+          <p:cNvPr id="5" name="Image 0" descr="preencoded.png"/>
           <p:cNvPicPr>
             <a:picLocks noChangeAspect="1"/>
           </p:cNvPicPr>
@@ -19749,7 +19749,7 @@
       </p:sp>
       <p:pic>
         <p:nvPicPr>
-          <p:cNvPr id="6" name="Image 0" descr="preencoded.png">    </p:cNvPr>
+          <p:cNvPr id="6" name="Image 0" descr="preencoded.png"/>
           <p:cNvPicPr>
             <a:picLocks noChangeAspect="1"/>
           </p:cNvPicPr>
@@ -19898,7 +19898,7 @@
       </p:sp>
       <p:pic>
         <p:nvPicPr>
-          <p:cNvPr id="11" name="Image 1" descr="preencoded.png">    </p:cNvPr>
+          <p:cNvPr id="11" name="Image 1" descr="preencoded.png"/>
           <p:cNvPicPr>
             <a:picLocks noChangeAspect="1"/>
           </p:cNvPicPr>
@@ -20047,7 +20047,7 @@
       </p:sp>
       <p:pic>
         <p:nvPicPr>
-          <p:cNvPr id="16" name="Image 2" descr="preencoded.png">    </p:cNvPr>
+          <p:cNvPr id="16" name="Image 2" descr="preencoded.png"/>
           <p:cNvPicPr>
             <a:picLocks noChangeAspect="1"/>
           </p:cNvPicPr>
@@ -20196,7 +20196,7 @@
       </p:sp>
       <p:pic>
         <p:nvPicPr>
-          <p:cNvPr id="21" name="Image 3" descr="preencoded.png">    </p:cNvPr>
+          <p:cNvPr id="21" name="Image 3" descr="preencoded.png"/>
           <p:cNvPicPr>
             <a:picLocks noChangeAspect="1"/>
           </p:cNvPicPr>
@@ -20666,7 +20666,7 @@
       </p:sp>
       <p:pic>
         <p:nvPicPr>
-          <p:cNvPr id="8" name="Image 0" descr="preencoded.png">    </p:cNvPr>
+          <p:cNvPr id="8" name="Image 0" descr="preencoded.png"/>
           <p:cNvPicPr>
             <a:picLocks noChangeAspect="1"/>
           </p:cNvPicPr>
@@ -20768,7 +20768,7 @@
       </p:sp>
       <p:pic>
         <p:nvPicPr>
-          <p:cNvPr id="11" name="Image 1" descr="preencoded.png">    </p:cNvPr>
+          <p:cNvPr id="11" name="Image 1" descr="preencoded.png"/>
           <p:cNvPicPr>
             <a:picLocks noChangeAspect="1"/>
           </p:cNvPicPr>
@@ -20870,7 +20870,7 @@
       </p:sp>
       <p:pic>
         <p:nvPicPr>
-          <p:cNvPr id="14" name="Image 2" descr="preencoded.png">    </p:cNvPr>
+          <p:cNvPr id="14" name="Image 2" descr="preencoded.png"/>
           <p:cNvPicPr>
             <a:picLocks noChangeAspect="1"/>
           </p:cNvPicPr>
@@ -20972,7 +20972,7 @@
       </p:sp>
       <p:pic>
         <p:nvPicPr>
-          <p:cNvPr id="17" name="Image 3" descr="preencoded.png">    </p:cNvPr>
+          <p:cNvPr id="17" name="Image 3" descr="preencoded.png"/>
           <p:cNvPicPr>
             <a:picLocks noChangeAspect="1"/>
           </p:cNvPicPr>
@@ -21074,7 +21074,7 @@
       </p:sp>
       <p:pic>
         <p:nvPicPr>
-          <p:cNvPr id="20" name="Image 4" descr="preencoded.png">    </p:cNvPr>
+          <p:cNvPr id="20" name="Image 4" descr="preencoded.png"/>
           <p:cNvPicPr>
             <a:picLocks noChangeAspect="1"/>
           </p:cNvPicPr>
@@ -21411,7 +21411,7 @@
       </p:sp>
       <p:pic>
         <p:nvPicPr>
-          <p:cNvPr id="8" name="Image 0" descr="preencoded.png">    </p:cNvPr>
+          <p:cNvPr id="8" name="Image 0" descr="preencoded.png"/>
           <p:cNvPicPr>
             <a:picLocks noChangeAspect="1"/>
           </p:cNvPicPr>
@@ -21474,7 +21474,7 @@
       </p:sp>
       <p:pic>
         <p:nvPicPr>
-          <p:cNvPr id="10" name="Image 1" descr="preencoded.png">    </p:cNvPr>
+          <p:cNvPr id="10" name="Image 1" descr="preencoded.png"/>
           <p:cNvPicPr>
             <a:picLocks noChangeAspect="1"/>
           </p:cNvPicPr>
@@ -21537,7 +21537,7 @@
       </p:sp>
       <p:pic>
         <p:nvPicPr>
-          <p:cNvPr id="12" name="Image 2" descr="preencoded.png">    </p:cNvPr>
+          <p:cNvPr id="12" name="Image 2" descr="preencoded.png"/>
           <p:cNvPicPr>
             <a:picLocks noChangeAspect="1"/>
           </p:cNvPicPr>
@@ -21600,7 +21600,7 @@
       </p:sp>
       <p:pic>
         <p:nvPicPr>
-          <p:cNvPr id="14" name="Image 3" descr="preencoded.png">    </p:cNvPr>
+          <p:cNvPr id="14" name="Image 3" descr="preencoded.png"/>
           <p:cNvPicPr>
             <a:picLocks noChangeAspect="1"/>
           </p:cNvPicPr>
@@ -21663,7 +21663,7 @@
       </p:sp>
       <p:pic>
         <p:nvPicPr>
-          <p:cNvPr id="16" name="Image 4" descr="preencoded.png">    </p:cNvPr>
+          <p:cNvPr id="16" name="Image 4" descr="preencoded.png"/>
           <p:cNvPicPr>
             <a:picLocks noChangeAspect="1"/>
           </p:cNvPicPr>
@@ -21726,7 +21726,7 @@
       </p:sp>
       <p:pic>
         <p:nvPicPr>
-          <p:cNvPr id="18" name="Image 5" descr="preencoded.png">    </p:cNvPr>
+          <p:cNvPr id="18" name="Image 5" descr="preencoded.png"/>
           <p:cNvPicPr>
             <a:picLocks noChangeAspect="1"/>
           </p:cNvPicPr>
@@ -21789,7 +21789,7 @@
       </p:sp>
       <p:pic>
         <p:nvPicPr>
-          <p:cNvPr id="20" name="Image 6" descr="preencoded.png">    </p:cNvPr>
+          <p:cNvPr id="20" name="Image 6" descr="preencoded.png"/>
           <p:cNvPicPr>
             <a:picLocks noChangeAspect="1"/>
           </p:cNvPicPr>
@@ -21852,7 +21852,7 @@
       </p:sp>
       <p:pic>
         <p:nvPicPr>
-          <p:cNvPr id="22" name="Image 7" descr="preencoded.png">    </p:cNvPr>
+          <p:cNvPr id="22" name="Image 7" descr="preencoded.png"/>
           <p:cNvPicPr>
             <a:picLocks noChangeAspect="1"/>
           </p:cNvPicPr>
@@ -22040,7 +22040,7 @@
       </p:sp>
       <p:pic>
         <p:nvPicPr>
-          <p:cNvPr id="28" name="Image 8" descr="preencoded.png">    </p:cNvPr>
+          <p:cNvPr id="28" name="Image 8" descr="preencoded.png"/>
           <p:cNvPicPr>
             <a:picLocks noChangeAspect="1"/>
           </p:cNvPicPr>
@@ -22103,7 +22103,7 @@
       </p:sp>
       <p:pic>
         <p:nvPicPr>
-          <p:cNvPr id="30" name="Image 9" descr="preencoded.png">    </p:cNvPr>
+          <p:cNvPr id="30" name="Image 9" descr="preencoded.png"/>
           <p:cNvPicPr>
             <a:picLocks noChangeAspect="1"/>
           </p:cNvPicPr>
@@ -22166,7 +22166,7 @@
       </p:sp>
       <p:pic>
         <p:nvPicPr>
-          <p:cNvPr id="32" name="Image 10" descr="preencoded.png">    </p:cNvPr>
+          <p:cNvPr id="32" name="Image 10" descr="preencoded.png"/>
           <p:cNvPicPr>
             <a:picLocks noChangeAspect="1"/>
           </p:cNvPicPr>
@@ -22229,7 +22229,7 @@
       </p:sp>
       <p:pic>
         <p:nvPicPr>
-          <p:cNvPr id="34" name="Image 11" descr="preencoded.png">    </p:cNvPr>
+          <p:cNvPr id="34" name="Image 11" descr="preencoded.png"/>
           <p:cNvPicPr>
             <a:picLocks noChangeAspect="1"/>
           </p:cNvPicPr>
@@ -22292,7 +22292,7 @@
       </p:sp>
       <p:pic>
         <p:nvPicPr>
-          <p:cNvPr id="36" name="Image 12" descr="preencoded.png">    </p:cNvPr>
+          <p:cNvPr id="36" name="Image 12" descr="preencoded.png"/>
           <p:cNvPicPr>
             <a:picLocks noChangeAspect="1"/>
           </p:cNvPicPr>
@@ -22355,7 +22355,7 @@
       </p:sp>
       <p:pic>
         <p:nvPicPr>
-          <p:cNvPr id="38" name="Image 13" descr="preencoded.png">    </p:cNvPr>
+          <p:cNvPr id="38" name="Image 13" descr="preencoded.png"/>
           <p:cNvPicPr>
             <a:picLocks noChangeAspect="1"/>
           </p:cNvPicPr>
@@ -22418,7 +22418,7 @@
       </p:sp>
       <p:pic>
         <p:nvPicPr>
-          <p:cNvPr id="40" name="Image 14" descr="preencoded.png">    </p:cNvPr>
+          <p:cNvPr id="40" name="Image 14" descr="preencoded.png"/>
           <p:cNvPicPr>
             <a:picLocks noChangeAspect="1"/>
           </p:cNvPicPr>
@@ -22481,7 +22481,7 @@
       </p:sp>
       <p:pic>
         <p:nvPicPr>
-          <p:cNvPr id="42" name="Image 15" descr="preencoded.png">    </p:cNvPr>
+          <p:cNvPr id="42" name="Image 15" descr="preencoded.png"/>
           <p:cNvPicPr>
             <a:picLocks noChangeAspect="1"/>
           </p:cNvPicPr>
@@ -23783,7 +23783,7 @@
       </p:sp>
       <p:pic>
         <p:nvPicPr>
-          <p:cNvPr id="39" name="Image 0" descr="preencoded.png">    </p:cNvPr>
+          <p:cNvPr id="39" name="Image 0" descr="preencoded.png"/>
           <p:cNvPicPr>
             <a:picLocks noChangeAspect="1"/>
           </p:cNvPicPr>

</xml_diff>